<commit_message>
Text Generation Playground: new name, wording and docs
- Rename the app to Text Generation Playground; new page text,
  prompt placeholder and system prompt
- README: describe the build on its own terms; add a Design decisions table
- Update the architecture deck's title slide and footers
</commit_message>
<xml_diff>
--- a/09-ai-competencies/inference-model-apis/text-generation-app/docs/architecture.pptx
+++ b/09-ai-competencies/inference-model-apis/text-generation-app/docs/architecture.pptx
@@ -3865,7 +3865,7 @@
                 </a:solidFill>
                 <a:latin typeface="Calibri"/>
               </a:rPr>
-              <a:t>Simple Text Generation App</a:t>
+              <a:t>Text Generation Playground</a:t>
             </a:r>
           </a:p>
         </p:txBody>
@@ -3947,7 +3947,7 @@
                 </a:solidFill>
                 <a:latin typeface="Calibri"/>
               </a:rPr>
-              <a:t>A rebuild of “Building a Simple Text Generation App with Hugging Face Model APIs” (J. Raza, 2025)</a:t>
+              <a:t>Type a prompt, pick a model, get the answer streamed back</a:t>
             </a:r>
           </a:p>
         </p:txBody>
@@ -6001,7 +6001,7 @@
                 </a:solidFill>
                 <a:latin typeface="Calibri"/>
               </a:rPr>
-              <a:t>Simple Text Generation App  ·  09-ai-competencies/inference-model-apis/text-generation-app</a:t>
+              <a:t>Text Generation Playground  ·  09-ai-competencies/inference-model-apis/text-generation-app</a:t>
             </a:r>
           </a:p>
         </p:txBody>
@@ -7398,7 +7398,7 @@
                 </a:solidFill>
                 <a:latin typeface="Calibri"/>
               </a:rPr>
-              <a:t>Simple Text Generation App  ·  09-ai-competencies/inference-model-apis/text-generation-app</a:t>
+              <a:t>Text Generation Playground  ·  09-ai-competencies/inference-model-apis/text-generation-app</a:t>
             </a:r>
           </a:p>
         </p:txBody>
@@ -8229,7 +8229,7 @@
                 </a:solidFill>
                 <a:latin typeface="Calibri"/>
               </a:rPr>
-              <a:t>Simple Text Generation App  ·  09-ai-competencies/inference-model-apis/text-generation-app</a:t>
+              <a:t>Text Generation Playground  ·  09-ai-competencies/inference-model-apis/text-generation-app</a:t>
             </a:r>
           </a:p>
         </p:txBody>
@@ -9634,7 +9634,7 @@
                 </a:solidFill>
                 <a:latin typeface="Calibri"/>
               </a:rPr>
-              <a:t>Simple Text Generation App  ·  09-ai-competencies/inference-model-apis/text-generation-app</a:t>
+              <a:t>Text Generation Playground  ·  09-ai-competencies/inference-model-apis/text-generation-app</a:t>
             </a:r>
           </a:p>
         </p:txBody>

</xml_diff>